<commit_message>
Presentasi: tambah slide Skenario Pengujian, Cara Kerja Uji & identitas penyaji
- Slide 3 "Skenario Pengujian": parameter uji (30 konkuren, target /deploy, --nodes=1:3, kriteria sukses)
- Slide 5 "Cara Kerja Uji": alur 5 langkah beban -> autoscaling
- Slide judul: nama penyaji (Muhamad Alfan 18119033) & dosen pembimbing

Co-Authored-By: Claude Opus 4.8 <noreply@anthropic.com>
</commit_message>
<xml_diff>
--- a/presentasi/Presentasi_Autoscaling_2Jul2026.pptx
+++ b/presentasi/Presentasi_Autoscaling_2Jul2026.pptx
@@ -7,7 +7,9 @@
   <p:sldIdLst>
     <p:sldId id="256" r:id="rId2"/>
     <p:sldId id="257" r:id="rId3"/>
+    <p:sldId id="264" r:id="rId15"/>
     <p:sldId id="258" r:id="rId4"/>
+    <p:sldId id="265" r:id="rId16"/>
     <p:sldId id="259" r:id="rId5"/>
     <p:sldId id="260" r:id="rId6"/>
     <p:sldId id="261" r:id="rId7"/>
@@ -1916,6 +1918,1002 @@
           </a:p>
         </p:txBody>
       </p:sp>
+      <p:sp>
+        <p:nvSpPr>
+          <p:cNvPr id="13" name="Text Penyaji Label"/>
+          <p:cNvSpPr/>
+          <p:nvPr/>
+        </p:nvSpPr>
+        <p:spPr>
+          <a:xfrm>
+            <a:off x="8686800" y="5150000"/>
+            <a:ext cx="3048000" cy="260000"/>
+          </a:xfrm>
+          <a:prstGeom prst="rect">
+            <a:avLst/>
+          </a:prstGeom>
+          <a:noFill/>
+          <a:ln/>
+        </p:spPr>
+        <p:txBody>
+          <a:bodyPr wrap="square" rtlCol="0" anchor="ctr"/>
+          <a:lstStyle/>
+          <a:p>
+            <a:pPr algn="r" indent="0" marL="0">
+              <a:buNone/>
+            </a:pPr>
+            <a:r>
+              <a:rPr lang="en-US" sz="1050" b="1" spc="200" kern="0" dirty="0">
+                <a:solidFill>
+                  <a:srgbClr val="00A6A6"/>
+                </a:solidFill>
+                <a:latin typeface="Calibri" pitchFamily="34" charset="0"/>
+                <a:ea typeface="Calibri" pitchFamily="34" charset="-122"/>
+                <a:cs typeface="Calibri" pitchFamily="34" charset="-120"/>
+              </a:rPr>
+              <a:t>PENYAJI</a:t>
+            </a:r>
+            <a:endParaRPr lang="en-US" sz="1050" dirty="0"/>
+          </a:p>
+        </p:txBody>
+      </p:sp>
+      <p:sp>
+        <p:nvSpPr>
+          <p:cNvPr id="14" name="Text Penyaji Nama"/>
+          <p:cNvSpPr/>
+          <p:nvPr/>
+        </p:nvSpPr>
+        <p:spPr>
+          <a:xfrm>
+            <a:off x="8686800" y="5410000"/>
+            <a:ext cx="3048000" cy="330000"/>
+          </a:xfrm>
+          <a:prstGeom prst="rect">
+            <a:avLst/>
+          </a:prstGeom>
+          <a:noFill/>
+          <a:ln/>
+        </p:spPr>
+        <p:txBody>
+          <a:bodyPr wrap="square" rtlCol="0" anchor="ctr"/>
+          <a:lstStyle/>
+          <a:p>
+            <a:pPr algn="r" indent="0" marL="0">
+              <a:buNone/>
+            </a:pPr>
+            <a:r>
+              <a:rPr lang="en-US" sz="1500" b="1" dirty="0">
+                <a:solidFill>
+                  <a:srgbClr val="FFFFFF"/>
+                </a:solidFill>
+                <a:latin typeface="Cambria" pitchFamily="34" charset="0"/>
+                <a:ea typeface="Cambria" pitchFamily="34" charset="-122"/>
+                <a:cs typeface="Cambria" pitchFamily="34" charset="-120"/>
+              </a:rPr>
+              <a:t>Muhamad Alfan · 18119033</a:t>
+            </a:r>
+            <a:endParaRPr lang="en-US" sz="1500" dirty="0"/>
+          </a:p>
+        </p:txBody>
+      </p:sp>
+      <p:sp>
+        <p:nvSpPr>
+          <p:cNvPr id="15" name="Text Dosen Label"/>
+          <p:cNvSpPr/>
+          <p:nvPr/>
+        </p:nvSpPr>
+        <p:spPr>
+          <a:xfrm>
+            <a:off x="8686800" y="5800000"/>
+            <a:ext cx="3048000" cy="260000"/>
+          </a:xfrm>
+          <a:prstGeom prst="rect">
+            <a:avLst/>
+          </a:prstGeom>
+          <a:noFill/>
+          <a:ln/>
+        </p:spPr>
+        <p:txBody>
+          <a:bodyPr wrap="square" rtlCol="0" anchor="ctr"/>
+          <a:lstStyle/>
+          <a:p>
+            <a:pPr algn="r" indent="0" marL="0">
+              <a:buNone/>
+            </a:pPr>
+            <a:r>
+              <a:rPr lang="en-US" sz="1050" b="1" spc="200" kern="0" dirty="0">
+                <a:solidFill>
+                  <a:srgbClr val="00A6A6"/>
+                </a:solidFill>
+                <a:latin typeface="Calibri" pitchFamily="34" charset="0"/>
+                <a:ea typeface="Calibri" pitchFamily="34" charset="-122"/>
+                <a:cs typeface="Calibri" pitchFamily="34" charset="-120"/>
+              </a:rPr>
+              <a:t>DOSEN PEMBIMBING</a:t>
+            </a:r>
+            <a:endParaRPr lang="en-US" sz="1050" dirty="0"/>
+          </a:p>
+        </p:txBody>
+      </p:sp>
+      <p:sp>
+        <p:nvSpPr>
+          <p:cNvPr id="16" name="Text Dosen Nama"/>
+          <p:cNvSpPr/>
+          <p:nvPr/>
+        </p:nvSpPr>
+        <p:spPr>
+          <a:xfrm>
+            <a:off x="7686800" y="6060000"/>
+            <a:ext cx="4048000" cy="300000"/>
+          </a:xfrm>
+          <a:prstGeom prst="rect">
+            <a:avLst/>
+          </a:prstGeom>
+          <a:noFill/>
+          <a:ln/>
+        </p:spPr>
+        <p:txBody>
+          <a:bodyPr wrap="square" rtlCol="0" anchor="ctr"/>
+          <a:lstStyle/>
+          <a:p>
+            <a:pPr algn="r" indent="0" marL="0">
+              <a:buNone/>
+            </a:pPr>
+            <a:r>
+              <a:rPr lang="en-US" sz="1300" dirty="0">
+                <a:solidFill>
+                  <a:srgbClr val="AFC3D2"/>
+                </a:solidFill>
+                <a:latin typeface="Calibri" pitchFamily="34" charset="0"/>
+                <a:ea typeface="Calibri" pitchFamily="34" charset="-122"/>
+                <a:cs typeface="Calibri" pitchFamily="34" charset="-120"/>
+              </a:rPr>
+              <a:t>Dr. Hamonangan Situmorang, S.T., M.T.</a:t>
+            </a:r>
+            <a:endParaRPr lang="en-US" sz="1300" dirty="0"/>
+          </a:p>
+        </p:txBody>
+      </p:sp>
+    </p:spTree>
+  </p:cSld>
+  <p:clrMapOvr>
+    <a:masterClrMapping/>
+  </p:clrMapOvr>
+</p:sld>
+</file>
+
+<file path=ppt/slides/slide10.xml><?xml version="1.0" encoding="utf-8"?>
+<p:sld xmlns:a="http://schemas.openxmlformats.org/drawingml/2006/main" xmlns:r="http://schemas.openxmlformats.org/officeDocument/2006/relationships" xmlns:p="http://schemas.openxmlformats.org/presentationml/2006/main">
+  <p:cSld name="Slide Cara Kerja">
+    <p:bg>
+      <p:bgPr>
+        <a:solidFill>
+          <a:srgbClr val="FFFFFF"/>
+        </a:solidFill>
+      </p:bgPr>
+    </p:bg>
+    <p:spTree>
+      <p:nvGrpSpPr>
+        <p:cNvPr id="1" name=""/>
+        <p:cNvGrpSpPr/>
+        <p:nvPr/>
+      </p:nvGrpSpPr>
+      <p:grpSpPr>
+        <a:xfrm>
+          <a:off x="0" y="0"/>
+          <a:ext cx="0" cy="0"/>
+          <a:chOff x="0" y="0"/>
+          <a:chExt cx="0" cy="0"/>
+        </a:xfrm>
+      </p:grpSpPr>
+      <p:sp>
+        <p:nvSpPr>
+          <p:cNvPr id="2" name="Eyebrow"/>
+          <p:cNvSpPr/>
+          <p:nvPr/>
+        </p:nvSpPr>
+        <p:spPr>
+          <a:xfrm>
+            <a:off x="640080" y="457200"/>
+            <a:ext cx="10911535" cy="274320"/>
+          </a:xfrm>
+          <a:prstGeom prst="rect">
+            <a:avLst/>
+          </a:prstGeom>
+          <a:noFill/>
+          <a:ln/>
+        </p:spPr>
+        <p:txBody>
+          <a:bodyPr wrap="square" rtlCol="0" anchor="ctr"/>
+          <a:lstStyle/>
+          <a:p>
+            <a:pPr indent="0" marL="0">
+              <a:buNone/>
+            </a:pPr>
+            <a:r>
+              <a:rPr lang="en-US" sz="1200" b="1" spc="200" kern="0" dirty="0">
+                <a:solidFill>
+                  <a:srgbClr val="00A6A6"/>
+                </a:solidFill>
+                <a:latin typeface="Calibri" pitchFamily="34" charset="0"/>
+                <a:ea typeface="Calibri" pitchFamily="34" charset="-122"/>
+                <a:cs typeface="Calibri" pitchFamily="34" charset="-120"/>
+              </a:rPr>
+              <a:t>CARA KERJA UJI</a:t>
+            </a:r>
+            <a:endParaRPr lang="en-US" sz="1200" dirty="0"/>
+          </a:p>
+        </p:txBody>
+      </p:sp>
+      <p:sp>
+        <p:nvSpPr>
+          <p:cNvPr id="3" name="Title"/>
+          <p:cNvSpPr/>
+          <p:nvPr/>
+        </p:nvSpPr>
+        <p:spPr>
+          <a:xfrm>
+            <a:off x="640080" y="713232"/>
+            <a:ext cx="10911535" cy="731520"/>
+          </a:xfrm>
+          <a:prstGeom prst="rect">
+            <a:avLst/>
+          </a:prstGeom>
+          <a:noFill/>
+          <a:ln/>
+        </p:spPr>
+        <p:txBody>
+          <a:bodyPr wrap="square" rtlCol="0" anchor="ctr"/>
+          <a:lstStyle/>
+          <a:p>
+            <a:pPr indent="0" marL="0">
+              <a:buNone/>
+            </a:pPr>
+            <a:r>
+              <a:rPr lang="en-US" sz="3000" b="1" dirty="0">
+                <a:solidFill>
+                  <a:srgbClr val="1E2933"/>
+                </a:solidFill>
+                <a:latin typeface="Cambria" pitchFamily="34" charset="0"/>
+                <a:ea typeface="Cambria" pitchFamily="34" charset="-122"/>
+                <a:cs typeface="Cambria" pitchFamily="34" charset="-120"/>
+              </a:rPr>
+              <a:t>Alur: Beban → Autoscaling</a:t>
+            </a:r>
+            <a:endParaRPr lang="en-US" sz="3000" dirty="0"/>
+          </a:p>
+        </p:txBody>
+      </p:sp>
+      <p:sp>
+        <p:nvSpPr>
+          <p:cNvPr id="10" name="Row1 BG"/>
+          <p:cNvSpPr/>
+          <p:nvPr/>
+        </p:nvSpPr>
+        <p:spPr>
+          <a:xfrm>
+            <a:off x="640080" y="1650000"/>
+            <a:ext cx="10911535" cy="880000"/>
+          </a:xfrm>
+          <a:prstGeom prst="roundRect">
+            <a:avLst>
+              <a:gd name="adj" fmla="val 8000"/>
+            </a:avLst>
+          </a:prstGeom>
+          <a:solidFill>
+            <a:srgbClr val="F3F6F8"/>
+          </a:solidFill>
+          <a:ln w="12700">
+            <a:solidFill>
+              <a:srgbClr val="E1E8ED"/>
+            </a:solidFill>
+            <a:prstDash val="solid"/>
+          </a:ln>
+        </p:spPr>
+      </p:sp>
+      <p:sp>
+        <p:nvSpPr>
+          <p:cNvPr id="11" name="Row1 Circle"/>
+          <p:cNvSpPr/>
+          <p:nvPr/>
+        </p:nvSpPr>
+        <p:spPr>
+          <a:xfrm>
+            <a:off x="914400" y="1861400"/>
+            <a:ext cx="457200" cy="457200"/>
+          </a:xfrm>
+          <a:prstGeom prst="ellipse">
+            <a:avLst/>
+          </a:prstGeom>
+          <a:solidFill>
+            <a:srgbClr val="00A6A6"/>
+          </a:solidFill>
+          <a:ln/>
+        </p:spPr>
+        <p:txBody>
+          <a:bodyPr wrap="square" rtlCol="0" anchor="ctr"/>
+          <a:lstStyle/>
+          <a:p>
+            <a:pPr algn="ctr" indent="0" marL="0">
+              <a:buNone/>
+            </a:pPr>
+            <a:r>
+              <a:rPr lang="en-US" sz="1800" b="1" dirty="0">
+                <a:solidFill>
+                  <a:srgbClr val="FFFFFF"/>
+                </a:solidFill>
+                <a:latin typeface="Cambria" pitchFamily="34" charset="0"/>
+                <a:ea typeface="Cambria" pitchFamily="34" charset="-122"/>
+                <a:cs typeface="Cambria" pitchFamily="34" charset="-120"/>
+              </a:rPr>
+              <a:t>1</a:t>
+            </a:r>
+            <a:endParaRPr lang="en-US" sz="1800" dirty="0"/>
+          </a:p>
+        </p:txBody>
+      </p:sp>
+      <p:sp>
+        <p:nvSpPr>
+          <p:cNvPr id="12" name="Row1 Title"/>
+          <p:cNvSpPr/>
+          <p:nvPr/>
+        </p:nvSpPr>
+        <p:spPr>
+          <a:xfrm>
+            <a:off x="1600200" y="1740000"/>
+            <a:ext cx="9600000" cy="330000"/>
+          </a:xfrm>
+          <a:prstGeom prst="rect">
+            <a:avLst/>
+          </a:prstGeom>
+          <a:noFill/>
+          <a:ln/>
+        </p:spPr>
+        <p:txBody>
+          <a:bodyPr wrap="square" rtlCol="0" anchor="ctr"/>
+          <a:lstStyle/>
+          <a:p>
+            <a:pPr indent="0" marL="0">
+              <a:buNone/>
+            </a:pPr>
+            <a:r>
+              <a:rPr lang="en-US" sz="1550" b="1" dirty="0">
+                <a:solidFill>
+                  <a:srgbClr val="0F2A43"/>
+                </a:solidFill>
+                <a:latin typeface="Cambria" pitchFamily="34" charset="0"/>
+                <a:ea typeface="Cambria" pitchFamily="34" charset="-122"/>
+                <a:cs typeface="Cambria" pitchFamily="34" charset="-120"/>
+              </a:rPr>
+              <a:t>Pemicu beban</a:t>
+            </a:r>
+            <a:endParaRPr lang="en-US" sz="1550" dirty="0"/>
+          </a:p>
+        </p:txBody>
+      </p:sp>
+      <p:sp>
+        <p:nvSpPr>
+          <p:cNvPr id="13" name="Row1 Desc"/>
+          <p:cNvSpPr/>
+          <p:nvPr/>
+        </p:nvSpPr>
+        <p:spPr>
+          <a:xfrm>
+            <a:off x="1600200" y="2080000"/>
+            <a:ext cx="9600000" cy="340000"/>
+          </a:xfrm>
+          <a:prstGeom prst="rect">
+            <a:avLst/>
+          </a:prstGeom>
+          <a:noFill/>
+          <a:ln/>
+        </p:spPr>
+        <p:txBody>
+          <a:bodyPr wrap="square" rtlCol="0" anchor="ctr"/>
+          <a:lstStyle/>
+          <a:p>
+            <a:pPr indent="0" marL="0">
+              <a:buNone/>
+            </a:pPr>
+            <a:r>
+              <a:rPr lang="en-US" sz="1300" dirty="0">
+                <a:solidFill>
+                  <a:srgbClr val="1E2933"/>
+                </a:solidFill>
+                <a:latin typeface="Calibri" pitchFamily="34" charset="0"/>
+                <a:ea typeface="Calibri" pitchFamily="34" charset="-122"/>
+                <a:cs typeface="Calibri" pitchFamily="34" charset="-120"/>
+              </a:rPr>
+              <a:t>Job loadtest-labs mengirim 30 permintaan POST /deploy serentak (loop for + curl &amp;) — meniru 30 mahasiswa klik Launch Lab bersamaan.</a:t>
+            </a:r>
+            <a:endParaRPr lang="en-US" sz="1300" dirty="0"/>
+          </a:p>
+        </p:txBody>
+      </p:sp>
+      <p:sp>
+        <p:nvSpPr>
+          <p:cNvPr id="20" name="Row2 BG"/>
+          <p:cNvSpPr/>
+          <p:nvPr/>
+        </p:nvSpPr>
+        <p:spPr>
+          <a:xfrm>
+            <a:off x="640080" y="2578000"/>
+            <a:ext cx="10911535" cy="880000"/>
+          </a:xfrm>
+          <a:prstGeom prst="roundRect">
+            <a:avLst>
+              <a:gd name="adj" fmla="val 8000"/>
+            </a:avLst>
+          </a:prstGeom>
+          <a:solidFill>
+            <a:srgbClr val="F3F6F8"/>
+          </a:solidFill>
+          <a:ln w="12700">
+            <a:solidFill>
+              <a:srgbClr val="E1E8ED"/>
+            </a:solidFill>
+            <a:prstDash val="solid"/>
+          </a:ln>
+        </p:spPr>
+      </p:sp>
+      <p:sp>
+        <p:nvSpPr>
+          <p:cNvPr id="21" name="Row2 Circle"/>
+          <p:cNvSpPr/>
+          <p:nvPr/>
+        </p:nvSpPr>
+        <p:spPr>
+          <a:xfrm>
+            <a:off x="914400" y="2789400"/>
+            <a:ext cx="457200" cy="457200"/>
+          </a:xfrm>
+          <a:prstGeom prst="ellipse">
+            <a:avLst/>
+          </a:prstGeom>
+          <a:solidFill>
+            <a:srgbClr val="0F2A43"/>
+          </a:solidFill>
+          <a:ln/>
+        </p:spPr>
+        <p:txBody>
+          <a:bodyPr wrap="square" rtlCol="0" anchor="ctr"/>
+          <a:lstStyle/>
+          <a:p>
+            <a:pPr algn="ctr" indent="0" marL="0">
+              <a:buNone/>
+            </a:pPr>
+            <a:r>
+              <a:rPr lang="en-US" sz="1800" b="1" dirty="0">
+                <a:solidFill>
+                  <a:srgbClr val="FFFFFF"/>
+                </a:solidFill>
+                <a:latin typeface="Cambria" pitchFamily="34" charset="0"/>
+                <a:ea typeface="Cambria" pitchFamily="34" charset="-122"/>
+                <a:cs typeface="Cambria" pitchFamily="34" charset="-120"/>
+              </a:rPr>
+              <a:t>2</a:t>
+            </a:r>
+            <a:endParaRPr lang="en-US" sz="1800" dirty="0"/>
+          </a:p>
+        </p:txBody>
+      </p:sp>
+      <p:sp>
+        <p:nvSpPr>
+          <p:cNvPr id="22" name="Row2 Title"/>
+          <p:cNvSpPr/>
+          <p:nvPr/>
+        </p:nvSpPr>
+        <p:spPr>
+          <a:xfrm>
+            <a:off x="1600200" y="2668000"/>
+            <a:ext cx="9600000" cy="330000"/>
+          </a:xfrm>
+          <a:prstGeom prst="rect">
+            <a:avLst/>
+          </a:prstGeom>
+          <a:noFill/>
+          <a:ln/>
+        </p:spPr>
+        <p:txBody>
+          <a:bodyPr wrap="square" rtlCol="0" anchor="ctr"/>
+          <a:lstStyle/>
+          <a:p>
+            <a:pPr indent="0" marL="0">
+              <a:buNone/>
+            </a:pPr>
+            <a:r>
+              <a:rPr lang="en-US" sz="1550" b="1" dirty="0">
+                <a:solidFill>
+                  <a:srgbClr val="0F2A43"/>
+                </a:solidFill>
+                <a:latin typeface="Cambria" pitchFamily="34" charset="0"/>
+                <a:ea typeface="Cambria" pitchFamily="34" charset="-122"/>
+                <a:cs typeface="Cambria" pitchFamily="34" charset="-120"/>
+              </a:rPr>
+              <a:t>Pembuatan lab</a:t>
+            </a:r>
+            <a:endParaRPr lang="en-US" sz="1550" dirty="0"/>
+          </a:p>
+        </p:txBody>
+      </p:sp>
+      <p:sp>
+        <p:nvSpPr>
+          <p:cNvPr id="23" name="Row2 Desc"/>
+          <p:cNvSpPr/>
+          <p:nvPr/>
+        </p:nvSpPr>
+        <p:spPr>
+          <a:xfrm>
+            <a:off x="1600200" y="3008000"/>
+            <a:ext cx="9600000" cy="340000"/>
+          </a:xfrm>
+          <a:prstGeom prst="rect">
+            <a:avLst/>
+          </a:prstGeom>
+          <a:noFill/>
+          <a:ln/>
+        </p:spPr>
+        <p:txBody>
+          <a:bodyPr wrap="square" rtlCol="0" anchor="ctr"/>
+          <a:lstStyle/>
+          <a:p>
+            <a:pPr indent="0" marL="0">
+              <a:buNone/>
+            </a:pPr>
+            <a:r>
+              <a:rPr lang="en-US" sz="1300" dirty="0">
+                <a:solidFill>
+                  <a:srgbClr val="1E2933"/>
+                </a:solidFill>
+                <a:latin typeface="Calibri" pitchFamily="34" charset="0"/>
+                <a:ea typeface="Calibri" pitchFamily="34" charset="-122"/>
+                <a:cs typeface="Calibri" pitchFamily="34" charset="-120"/>
+              </a:rPr>
+              <a:t>Orchestrator menerjemahkan tiap /deploy menjadi 1 Pod + Service + Ingress lab lewat Kubernetes API.</a:t>
+            </a:r>
+            <a:endParaRPr lang="en-US" sz="1300" dirty="0"/>
+          </a:p>
+        </p:txBody>
+      </p:sp>
+      <p:sp>
+        <p:nvSpPr>
+          <p:cNvPr id="30" name="Row3 BG"/>
+          <p:cNvSpPr/>
+          <p:nvPr/>
+        </p:nvSpPr>
+        <p:spPr>
+          <a:xfrm>
+            <a:off x="640080" y="3506000"/>
+            <a:ext cx="10911535" cy="880000"/>
+          </a:xfrm>
+          <a:prstGeom prst="roundRect">
+            <a:avLst>
+              <a:gd name="adj" fmla="val 8000"/>
+            </a:avLst>
+          </a:prstGeom>
+          <a:solidFill>
+            <a:srgbClr val="F3F6F8"/>
+          </a:solidFill>
+          <a:ln w="12700">
+            <a:solidFill>
+              <a:srgbClr val="E1E8ED"/>
+            </a:solidFill>
+            <a:prstDash val="solid"/>
+          </a:ln>
+        </p:spPr>
+      </p:sp>
+      <p:sp>
+        <p:nvSpPr>
+          <p:cNvPr id="31" name="Row3 Circle"/>
+          <p:cNvSpPr/>
+          <p:nvPr/>
+        </p:nvSpPr>
+        <p:spPr>
+          <a:xfrm>
+            <a:off x="914400" y="3717400"/>
+            <a:ext cx="457200" cy="457200"/>
+          </a:xfrm>
+          <a:prstGeom prst="ellipse">
+            <a:avLst/>
+          </a:prstGeom>
+          <a:solidFill>
+            <a:srgbClr val="E08A1E"/>
+          </a:solidFill>
+          <a:ln/>
+        </p:spPr>
+        <p:txBody>
+          <a:bodyPr wrap="square" rtlCol="0" anchor="ctr"/>
+          <a:lstStyle/>
+          <a:p>
+            <a:pPr algn="ctr" indent="0" marL="0">
+              <a:buNone/>
+            </a:pPr>
+            <a:r>
+              <a:rPr lang="en-US" sz="1800" b="1" dirty="0">
+                <a:solidFill>
+                  <a:srgbClr val="FFFFFF"/>
+                </a:solidFill>
+                <a:latin typeface="Cambria" pitchFamily="34" charset="0"/>
+                <a:ea typeface="Cambria" pitchFamily="34" charset="-122"/>
+                <a:cs typeface="Cambria" pitchFamily="34" charset="-120"/>
+              </a:rPr>
+              <a:t>3</a:t>
+            </a:r>
+            <a:endParaRPr lang="en-US" sz="1800" dirty="0"/>
+          </a:p>
+        </p:txBody>
+      </p:sp>
+      <p:sp>
+        <p:nvSpPr>
+          <p:cNvPr id="32" name="Row3 Title"/>
+          <p:cNvSpPr/>
+          <p:nvPr/>
+        </p:nvSpPr>
+        <p:spPr>
+          <a:xfrm>
+            <a:off x="1600200" y="3596000"/>
+            <a:ext cx="9600000" cy="330000"/>
+          </a:xfrm>
+          <a:prstGeom prst="rect">
+            <a:avLst/>
+          </a:prstGeom>
+          <a:noFill/>
+          <a:ln/>
+        </p:spPr>
+        <p:txBody>
+          <a:bodyPr wrap="square" rtlCol="0" anchor="ctr"/>
+          <a:lstStyle/>
+          <a:p>
+            <a:pPr indent="0" marL="0">
+              <a:buNone/>
+            </a:pPr>
+            <a:r>
+              <a:rPr lang="en-US" sz="1550" b="1" dirty="0">
+                <a:solidFill>
+                  <a:srgbClr val="0F2A43"/>
+                </a:solidFill>
+                <a:latin typeface="Cambria" pitchFamily="34" charset="0"/>
+                <a:ea typeface="Cambria" pitchFamily="34" charset="-122"/>
+                <a:cs typeface="Cambria" pitchFamily="34" charset="-120"/>
+              </a:rPr>
+              <a:t>Antrean (Pending)</a:t>
+            </a:r>
+            <a:endParaRPr lang="en-US" sz="1550" dirty="0"/>
+          </a:p>
+        </p:txBody>
+      </p:sp>
+      <p:sp>
+        <p:nvSpPr>
+          <p:cNvPr id="33" name="Row3 Desc"/>
+          <p:cNvSpPr/>
+          <p:nvPr/>
+        </p:nvSpPr>
+        <p:spPr>
+          <a:xfrm>
+            <a:off x="1600200" y="3936000"/>
+            <a:ext cx="9600000" cy="340000"/>
+          </a:xfrm>
+          <a:prstGeom prst="rect">
+            <a:avLst/>
+          </a:prstGeom>
+          <a:noFill/>
+          <a:ln/>
+        </p:spPr>
+        <p:txBody>
+          <a:bodyPr wrap="square" rtlCol="0" anchor="ctr"/>
+          <a:lstStyle/>
+          <a:p>
+            <a:pPr indent="0" marL="0">
+              <a:buNone/>
+            </a:pPr>
+            <a:r>
+              <a:rPr lang="en-US" sz="1300" dirty="0">
+                <a:solidFill>
+                  <a:srgbClr val="1E2933"/>
+                </a:solidFill>
+                <a:latin typeface="Calibri" pitchFamily="34" charset="0"/>
+                <a:ea typeface="Calibri" pitchFamily="34" charset="-122"/>
+                <a:cs typeface="Calibri" pitchFamily="34" charset="-120"/>
+              </a:rPr>
+              <a:t>Node awal penuh → sebagian Pod tak terjadwal (Pending) menumpuk sebagai sinyal kekurangan kapasitas.</a:t>
+            </a:r>
+            <a:endParaRPr lang="en-US" sz="1300" dirty="0"/>
+          </a:p>
+        </p:txBody>
+      </p:sp>
+      <p:sp>
+        <p:nvSpPr>
+          <p:cNvPr id="40" name="Row4 BG"/>
+          <p:cNvSpPr/>
+          <p:nvPr/>
+        </p:nvSpPr>
+        <p:spPr>
+          <a:xfrm>
+            <a:off x="640080" y="4434000"/>
+            <a:ext cx="10911535" cy="880000"/>
+          </a:xfrm>
+          <a:prstGeom prst="roundRect">
+            <a:avLst>
+              <a:gd name="adj" fmla="val 8000"/>
+            </a:avLst>
+          </a:prstGeom>
+          <a:solidFill>
+            <a:srgbClr val="F3F6F8"/>
+          </a:solidFill>
+          <a:ln w="12700">
+            <a:solidFill>
+              <a:srgbClr val="E1E8ED"/>
+            </a:solidFill>
+            <a:prstDash val="solid"/>
+          </a:ln>
+        </p:spPr>
+      </p:sp>
+      <p:sp>
+        <p:nvSpPr>
+          <p:cNvPr id="41" name="Row4 Circle"/>
+          <p:cNvSpPr/>
+          <p:nvPr/>
+        </p:nvSpPr>
+        <p:spPr>
+          <a:xfrm>
+            <a:off x="914400" y="4645400"/>
+            <a:ext cx="457200" cy="457200"/>
+          </a:xfrm>
+          <a:prstGeom prst="ellipse">
+            <a:avLst/>
+          </a:prstGeom>
+          <a:solidFill>
+            <a:srgbClr val="2FA36B"/>
+          </a:solidFill>
+          <a:ln/>
+        </p:spPr>
+        <p:txBody>
+          <a:bodyPr wrap="square" rtlCol="0" anchor="ctr"/>
+          <a:lstStyle/>
+          <a:p>
+            <a:pPr algn="ctr" indent="0" marL="0">
+              <a:buNone/>
+            </a:pPr>
+            <a:r>
+              <a:rPr lang="en-US" sz="1800" b="1" dirty="0">
+                <a:solidFill>
+                  <a:srgbClr val="FFFFFF"/>
+                </a:solidFill>
+                <a:latin typeface="Cambria" pitchFamily="34" charset="0"/>
+                <a:ea typeface="Cambria" pitchFamily="34" charset="-122"/>
+                <a:cs typeface="Cambria" pitchFamily="34" charset="-120"/>
+              </a:rPr>
+              <a:t>4</a:t>
+            </a:r>
+            <a:endParaRPr lang="en-US" sz="1800" dirty="0"/>
+          </a:p>
+        </p:txBody>
+      </p:sp>
+      <p:sp>
+        <p:nvSpPr>
+          <p:cNvPr id="42" name="Row4 Title"/>
+          <p:cNvSpPr/>
+          <p:nvPr/>
+        </p:nvSpPr>
+        <p:spPr>
+          <a:xfrm>
+            <a:off x="1600200" y="4524000"/>
+            <a:ext cx="9600000" cy="330000"/>
+          </a:xfrm>
+          <a:prstGeom prst="rect">
+            <a:avLst/>
+          </a:prstGeom>
+          <a:noFill/>
+          <a:ln/>
+        </p:spPr>
+        <p:txBody>
+          <a:bodyPr wrap="square" rtlCol="0" anchor="ctr"/>
+          <a:lstStyle/>
+          <a:p>
+            <a:pPr indent="0" marL="0">
+              <a:buNone/>
+            </a:pPr>
+            <a:r>
+              <a:rPr lang="en-US" sz="1550" b="1" dirty="0">
+                <a:solidFill>
+                  <a:srgbClr val="0F2A43"/>
+                </a:solidFill>
+                <a:latin typeface="Cambria" pitchFamily="34" charset="0"/>
+                <a:ea typeface="Cambria" pitchFamily="34" charset="-122"/>
+                <a:cs typeface="Cambria" pitchFamily="34" charset="-120"/>
+              </a:rPr>
+              <a:t>Respons autoscaler</a:t>
+            </a:r>
+            <a:endParaRPr lang="en-US" sz="1550" dirty="0"/>
+          </a:p>
+        </p:txBody>
+      </p:sp>
+      <p:sp>
+        <p:nvSpPr>
+          <p:cNvPr id="43" name="Row4 Desc"/>
+          <p:cNvSpPr/>
+          <p:nvPr/>
+        </p:nvSpPr>
+        <p:spPr>
+          <a:xfrm>
+            <a:off x="1600200" y="4864000"/>
+            <a:ext cx="9600000" cy="340000"/>
+          </a:xfrm>
+          <a:prstGeom prst="rect">
+            <a:avLst/>
+          </a:prstGeom>
+          <a:noFill/>
+          <a:ln/>
+        </p:spPr>
+        <p:txBody>
+          <a:bodyPr wrap="square" rtlCol="0" anchor="ctr"/>
+          <a:lstStyle/>
+          <a:p>
+            <a:pPr indent="0" marL="0">
+              <a:buNone/>
+            </a:pPr>
+            <a:r>
+              <a:rPr lang="en-US" sz="1300" dirty="0">
+                <a:solidFill>
+                  <a:srgbClr val="1E2933"/>
+                </a:solidFill>
+                <a:latin typeface="Calibri" pitchFamily="34" charset="0"/>
+                <a:ea typeface="Calibri" pitchFamily="34" charset="-122"/>
+                <a:cs typeface="Calibri" pitchFamily="34" charset="-120"/>
+              </a:rPr>
+              <a:t>Cluster Autoscaler mendeteksi Pod Pending → memesan node baru; node 1 → 3 (butuh ~4 mnt provisi A1).</a:t>
+            </a:r>
+            <a:endParaRPr lang="en-US" sz="1300" dirty="0"/>
+          </a:p>
+        </p:txBody>
+      </p:sp>
+      <p:sp>
+        <p:nvSpPr>
+          <p:cNvPr id="50" name="Row5 BG"/>
+          <p:cNvSpPr/>
+          <p:nvPr/>
+        </p:nvSpPr>
+        <p:spPr>
+          <a:xfrm>
+            <a:off x="640080" y="5362000"/>
+            <a:ext cx="10911535" cy="880000"/>
+          </a:xfrm>
+          <a:prstGeom prst="roundRect">
+            <a:avLst>
+              <a:gd name="adj" fmla="val 8000"/>
+            </a:avLst>
+          </a:prstGeom>
+          <a:solidFill>
+            <a:srgbClr val="ECF7F3"/>
+          </a:solidFill>
+          <a:ln w="12700">
+            <a:solidFill>
+              <a:srgbClr val="BFE6D8"/>
+            </a:solidFill>
+            <a:prstDash val="solid"/>
+          </a:ln>
+        </p:spPr>
+      </p:sp>
+      <p:sp>
+        <p:nvSpPr>
+          <p:cNvPr id="51" name="Row5 Circle"/>
+          <p:cNvSpPr/>
+          <p:nvPr/>
+        </p:nvSpPr>
+        <p:spPr>
+          <a:xfrm>
+            <a:off x="914400" y="5573400"/>
+            <a:ext cx="457200" cy="457200"/>
+          </a:xfrm>
+          <a:prstGeom prst="ellipse">
+            <a:avLst/>
+          </a:prstGeom>
+          <a:solidFill>
+            <a:srgbClr val="00A6A6"/>
+          </a:solidFill>
+          <a:ln/>
+        </p:spPr>
+        <p:txBody>
+          <a:bodyPr wrap="square" rtlCol="0" anchor="ctr"/>
+          <a:lstStyle/>
+          <a:p>
+            <a:pPr algn="ctr" indent="0" marL="0">
+              <a:buNone/>
+            </a:pPr>
+            <a:r>
+              <a:rPr lang="en-US" sz="1800" b="1" dirty="0">
+                <a:solidFill>
+                  <a:srgbClr val="FFFFFF"/>
+                </a:solidFill>
+                <a:latin typeface="Cambria" pitchFamily="34" charset="0"/>
+                <a:ea typeface="Cambria" pitchFamily="34" charset="-122"/>
+                <a:cs typeface="Cambria" pitchFamily="34" charset="-120"/>
+              </a:rPr>
+              <a:t>5</a:t>
+            </a:r>
+            <a:endParaRPr lang="en-US" sz="1800" dirty="0"/>
+          </a:p>
+        </p:txBody>
+      </p:sp>
+      <p:sp>
+        <p:nvSpPr>
+          <p:cNvPr id="52" name="Row5 Title"/>
+          <p:cNvSpPr/>
+          <p:nvPr/>
+        </p:nvSpPr>
+        <p:spPr>
+          <a:xfrm>
+            <a:off x="1600200" y="5452000"/>
+            <a:ext cx="9600000" cy="330000"/>
+          </a:xfrm>
+          <a:prstGeom prst="rect">
+            <a:avLst/>
+          </a:prstGeom>
+          <a:noFill/>
+          <a:ln/>
+        </p:spPr>
+        <p:txBody>
+          <a:bodyPr wrap="square" rtlCol="0" anchor="ctr"/>
+          <a:lstStyle/>
+          <a:p>
+            <a:pPr indent="0" marL="0">
+              <a:buNone/>
+            </a:pPr>
+            <a:r>
+              <a:rPr lang="en-US" sz="1550" b="1" dirty="0">
+                <a:solidFill>
+                  <a:srgbClr val="0F2A43"/>
+                </a:solidFill>
+                <a:latin typeface="Cambria" pitchFamily="34" charset="0"/>
+                <a:ea typeface="Cambria" pitchFamily="34" charset="-122"/>
+                <a:cs typeface="Cambria" pitchFamily="34" charset="-120"/>
+              </a:rPr>
+              <a:t>Pulih &amp; terekam</a:t>
+            </a:r>
+            <a:endParaRPr lang="en-US" sz="1550" dirty="0"/>
+          </a:p>
+        </p:txBody>
+      </p:sp>
+      <p:sp>
+        <p:nvSpPr>
+          <p:cNvPr id="53" name="Row5 Desc"/>
+          <p:cNvSpPr/>
+          <p:nvPr/>
+        </p:nvSpPr>
+        <p:spPr>
+          <a:xfrm>
+            <a:off x="1600200" y="5792000"/>
+            <a:ext cx="9600000" cy="340000"/>
+          </a:xfrm>
+          <a:prstGeom prst="rect">
+            <a:avLst/>
+          </a:prstGeom>
+          <a:noFill/>
+          <a:ln/>
+        </p:spPr>
+        <p:txBody>
+          <a:bodyPr wrap="square" rtlCol="0" anchor="ctr"/>
+          <a:lstStyle/>
+          <a:p>
+            <a:pPr indent="0" marL="0">
+              <a:buNone/>
+            </a:pPr>
+            <a:r>
+              <a:rPr lang="en-US" sz="1300" dirty="0">
+                <a:solidFill>
+                  <a:srgbClr val="1E2933"/>
+                </a:solidFill>
+                <a:latin typeface="Calibri" pitchFamily="34" charset="0"/>
+                <a:ea typeface="Calibri" pitchFamily="34" charset="-122"/>
+                <a:cs typeface="Calibri" pitchFamily="34" charset="-120"/>
+              </a:rPr>
+              <a:t>Pod terjadwal di node baru → Pending kembali 0. Logger CSV merekam seluruh proses tiap 10 detik untuk grafik.</a:t>
+            </a:r>
+            <a:endParaRPr lang="en-US" sz="1300" dirty="0"/>
+          </a:p>
+        </p:txBody>
+      </p:sp>
     </p:spTree>
   </p:cSld>
   <p:clrMapOvr>
@@ -3716,7 +4714,7 @@
       </p:sp>
       <p:pic>
         <p:nvPicPr>
-          <p:cNvPr id="4" name="Image 0" descr="C:/Users/aqila/AppData/Local/Temp/claude/C--Users-aqila-Downloads-Tugas-Akhir---Praktikum---LMS-Project-praktikum-lms-project-integrasi-backend/d082ad67-b66b-4431-9a31-4cc8f0386745/scratchpad/grafik_asli.png">    </p:cNvPr>
+          <p:cNvPr id="4" name="Image 0" descr="C:/Users/aqila/AppData/Local/Temp/claude/C--Users-aqila-Downloads-Tugas-Akhir---Praktikum---LMS-Project-praktikum-lms-project-integrasi-backend/d082ad67-b66b-4431-9a31-4cc8f0386745/scratchpad/grafik_asli.png"/>
           <p:cNvPicPr>
             <a:picLocks noChangeAspect="1"/>
           </p:cNvPicPr>
@@ -6654,6 +7652,928 @@
                 <a:cs typeface="Calibri" pitchFamily="34" charset="-120"/>
               </a:rPr>
               <a:t>① Grafik dengan pre-pull aktif (Running mencapai ~30)   ·   ② Grafik prediktif via scheduler (placeholder naik mendahului beban / Prophet)</a:t>
+            </a:r>
+            <a:endParaRPr lang="en-US" sz="1350" dirty="0"/>
+          </a:p>
+        </p:txBody>
+      </p:sp>
+    </p:spTree>
+  </p:cSld>
+  <p:clrMapOvr>
+    <a:masterClrMapping/>
+  </p:clrMapOvr>
+</p:sld>
+</file>
+
+<file path=ppt/slides/slide9.xml><?xml version="1.0" encoding="utf-8"?>
+<p:sld xmlns:a="http://schemas.openxmlformats.org/drawingml/2006/main" xmlns:r="http://schemas.openxmlformats.org/officeDocument/2006/relationships" xmlns:p="http://schemas.openxmlformats.org/presentationml/2006/main">
+  <p:cSld name="Slide 3">
+    <p:bg>
+      <p:bgPr>
+        <a:solidFill>
+          <a:srgbClr val="FFFFFF"/>
+        </a:solidFill>
+      </p:bgPr>
+    </p:bg>
+    <p:spTree>
+      <p:nvGrpSpPr>
+        <p:cNvPr id="1" name=""/>
+        <p:cNvGrpSpPr/>
+        <p:nvPr/>
+      </p:nvGrpSpPr>
+      <p:grpSpPr>
+        <a:xfrm>
+          <a:off x="0" y="0"/>
+          <a:ext cx="0" cy="0"/>
+          <a:chOff x="0" y="0"/>
+          <a:chExt cx="0" cy="0"/>
+        </a:xfrm>
+      </p:grpSpPr>
+      <p:sp>
+        <p:nvSpPr>
+          <p:cNvPr id="2" name="Text 0"/>
+          <p:cNvSpPr/>
+          <p:nvPr/>
+        </p:nvSpPr>
+        <p:spPr>
+          <a:xfrm>
+            <a:off x="640080" y="457200"/>
+            <a:ext cx="10911535" cy="274320"/>
+          </a:xfrm>
+          <a:prstGeom prst="rect">
+            <a:avLst/>
+          </a:prstGeom>
+          <a:noFill/>
+          <a:ln/>
+        </p:spPr>
+        <p:txBody>
+          <a:bodyPr wrap="square" rtlCol="0" anchor="ctr"/>
+          <a:lstStyle/>
+          <a:p>
+            <a:pPr indent="0" marL="0">
+              <a:buNone/>
+            </a:pPr>
+            <a:r>
+              <a:rPr lang="en-US" sz="1200" b="1" spc="200" kern="0" dirty="0">
+                <a:solidFill>
+                  <a:srgbClr val="00A6A6"/>
+                </a:solidFill>
+                <a:latin typeface="Calibri" pitchFamily="34" charset="0"/>
+                <a:ea typeface="Calibri" pitchFamily="34" charset="-122"/>
+                <a:cs typeface="Calibri" pitchFamily="34" charset="-120"/>
+              </a:rPr>
+              <a:t>SKENARIO PENGUJIAN</a:t>
+            </a:r>
+            <a:endParaRPr lang="en-US" sz="1200" dirty="0"/>
+          </a:p>
+        </p:txBody>
+      </p:sp>
+      <p:sp>
+        <p:nvSpPr>
+          <p:cNvPr id="3" name="Text 1"/>
+          <p:cNvSpPr/>
+          <p:nvPr/>
+        </p:nvSpPr>
+        <p:spPr>
+          <a:xfrm>
+            <a:off x="640080" y="713232"/>
+            <a:ext cx="10911535" cy="731520"/>
+          </a:xfrm>
+          <a:prstGeom prst="rect">
+            <a:avLst/>
+          </a:prstGeom>
+          <a:noFill/>
+          <a:ln/>
+        </p:spPr>
+        <p:txBody>
+          <a:bodyPr wrap="square" rtlCol="0" anchor="ctr"/>
+          <a:lstStyle/>
+          <a:p>
+            <a:pPr indent="0" marL="0">
+              <a:buNone/>
+            </a:pPr>
+            <a:r>
+              <a:rPr lang="en-US" sz="3000" b="1" dirty="0">
+                <a:solidFill>
+                  <a:srgbClr val="1E2933"/>
+                </a:solidFill>
+                <a:latin typeface="Cambria" pitchFamily="34" charset="0"/>
+                <a:ea typeface="Cambria" pitchFamily="34" charset="-122"/>
+                <a:cs typeface="Cambria" pitchFamily="34" charset="-120"/>
+              </a:rPr>
+              <a:t>Parameter &amp; Kriteria Uji</a:t>
+            </a:r>
+            <a:endParaRPr lang="en-US" sz="3000" dirty="0"/>
+          </a:p>
+        </p:txBody>
+      </p:sp>
+      <p:sp>
+        <p:nvSpPr>
+          <p:cNvPr id="4" name="Shape 2"/>
+          <p:cNvSpPr/>
+          <p:nvPr/>
+        </p:nvSpPr>
+        <p:spPr>
+          <a:xfrm>
+            <a:off x="640080" y="1783080"/>
+            <a:ext cx="5227168" cy="1965960"/>
+          </a:xfrm>
+          <a:prstGeom prst="roundRect">
+            <a:avLst>
+              <a:gd name="adj" fmla="val 3721"/>
+            </a:avLst>
+          </a:prstGeom>
+          <a:solidFill>
+            <a:srgbClr val="F3F6F8"/>
+          </a:solidFill>
+          <a:ln w="12700">
+            <a:solidFill>
+              <a:srgbClr val="E1E8ED"/>
+            </a:solidFill>
+            <a:prstDash val="solid"/>
+          </a:ln>
+        </p:spPr>
+      </p:sp>
+      <p:sp>
+        <p:nvSpPr>
+          <p:cNvPr id="5" name="Shape 3"/>
+          <p:cNvSpPr/>
+          <p:nvPr/>
+        </p:nvSpPr>
+        <p:spPr>
+          <a:xfrm>
+            <a:off x="914400" y="2075688"/>
+            <a:ext cx="457200" cy="457200"/>
+          </a:xfrm>
+          <a:prstGeom prst="ellipse">
+            <a:avLst/>
+          </a:prstGeom>
+          <a:solidFill>
+            <a:srgbClr val="00A6A6"/>
+          </a:solidFill>
+          <a:ln/>
+        </p:spPr>
+      </p:sp>
+      <p:sp>
+        <p:nvSpPr>
+          <p:cNvPr id="6" name="Text 4"/>
+          <p:cNvSpPr/>
+          <p:nvPr/>
+        </p:nvSpPr>
+        <p:spPr>
+          <a:xfrm>
+            <a:off x="914400" y="2075688"/>
+            <a:ext cx="457200" cy="457200"/>
+          </a:xfrm>
+          <a:prstGeom prst="rect">
+            <a:avLst/>
+          </a:prstGeom>
+          <a:noFill/>
+          <a:ln/>
+        </p:spPr>
+        <p:txBody>
+          <a:bodyPr wrap="square" rtlCol="0" anchor="ctr"/>
+          <a:lstStyle/>
+          <a:p>
+            <a:pPr algn="ctr" indent="0" marL="0">
+              <a:buNone/>
+            </a:pPr>
+            <a:r>
+              <a:rPr lang="en-US" sz="1800" b="1" dirty="0">
+                <a:solidFill>
+                  <a:srgbClr val="FFFFFF"/>
+                </a:solidFill>
+                <a:latin typeface="Cambria" pitchFamily="34" charset="0"/>
+                <a:ea typeface="Cambria" pitchFamily="34" charset="-122"/>
+                <a:cs typeface="Cambria" pitchFamily="34" charset="-120"/>
+              </a:rPr>
+              <a:t>1</a:t>
+            </a:r>
+            <a:endParaRPr lang="en-US" sz="1800" dirty="0"/>
+          </a:p>
+        </p:txBody>
+      </p:sp>
+      <p:sp>
+        <p:nvSpPr>
+          <p:cNvPr id="7" name="Text 5"/>
+          <p:cNvSpPr/>
+          <p:nvPr/>
+        </p:nvSpPr>
+        <p:spPr>
+          <a:xfrm>
+            <a:off x="1554480" y="2039112"/>
+            <a:ext cx="4038448" cy="365760"/>
+          </a:xfrm>
+          <a:prstGeom prst="rect">
+            <a:avLst/>
+          </a:prstGeom>
+          <a:noFill/>
+          <a:ln/>
+        </p:spPr>
+        <p:txBody>
+          <a:bodyPr wrap="square" rtlCol="0" anchor="ctr"/>
+          <a:lstStyle/>
+          <a:p>
+            <a:pPr indent="0" marL="0">
+              <a:buNone/>
+            </a:pPr>
+            <a:r>
+              <a:rPr lang="en-US" sz="1700" b="1" dirty="0">
+                <a:solidFill>
+                  <a:srgbClr val="0F2A43"/>
+                </a:solidFill>
+                <a:latin typeface="Cambria" pitchFamily="34" charset="0"/>
+                <a:ea typeface="Cambria" pitchFamily="34" charset="-122"/>
+                <a:cs typeface="Cambria" pitchFamily="34" charset="-120"/>
+              </a:rPr>
+              <a:t>Beban uji</a:t>
+            </a:r>
+            <a:endParaRPr lang="en-US" sz="1700" dirty="0"/>
+          </a:p>
+        </p:txBody>
+      </p:sp>
+      <p:sp>
+        <p:nvSpPr>
+          <p:cNvPr id="8" name="Text 6"/>
+          <p:cNvSpPr/>
+          <p:nvPr/>
+        </p:nvSpPr>
+        <p:spPr>
+          <a:xfrm>
+            <a:off x="1554480" y="2404872"/>
+            <a:ext cx="4038448" cy="320040"/>
+          </a:xfrm>
+          <a:prstGeom prst="rect">
+            <a:avLst/>
+          </a:prstGeom>
+          <a:noFill/>
+          <a:ln/>
+        </p:spPr>
+        <p:txBody>
+          <a:bodyPr wrap="square" rtlCol="0" anchor="ctr"/>
+          <a:lstStyle/>
+          <a:p>
+            <a:pPr indent="0" marL="0">
+              <a:buNone/>
+            </a:pPr>
+            <a:r>
+              <a:rPr lang="en-US" sz="1150" b="1" dirty="0">
+                <a:solidFill>
+                  <a:srgbClr val="00A6A6"/>
+                </a:solidFill>
+                <a:latin typeface="Consolas" pitchFamily="34" charset="0"/>
+                <a:ea typeface="Consolas" pitchFamily="34" charset="-122"/>
+                <a:cs typeface="Consolas" pitchFamily="34" charset="-120"/>
+              </a:rPr>
+              <a:t>loadtest-labs.yaml · N=30</a:t>
+            </a:r>
+            <a:endParaRPr lang="en-US" sz="1150" dirty="0"/>
+          </a:p>
+        </p:txBody>
+      </p:sp>
+      <p:sp>
+        <p:nvSpPr>
+          <p:cNvPr id="9" name="Text 7"/>
+          <p:cNvSpPr/>
+          <p:nvPr/>
+        </p:nvSpPr>
+        <p:spPr>
+          <a:xfrm>
+            <a:off x="914400" y="2834640"/>
+            <a:ext cx="4678528" cy="822960"/>
+          </a:xfrm>
+          <a:prstGeom prst="rect">
+            <a:avLst/>
+          </a:prstGeom>
+          <a:noFill/>
+          <a:ln/>
+        </p:spPr>
+        <p:txBody>
+          <a:bodyPr wrap="square" rtlCol="0" anchor="t"/>
+          <a:lstStyle/>
+          <a:p>
+            <a:pPr indent="0" marL="0">
+              <a:buNone/>
+            </a:pPr>
+            <a:r>
+              <a:rPr lang="en-US" sz="1350" dirty="0">
+                <a:solidFill>
+                  <a:srgbClr val="1E2933"/>
+                </a:solidFill>
+                <a:latin typeface="Calibri" pitchFamily="34" charset="0"/>
+                <a:ea typeface="Calibri" pitchFamily="34" charset="-122"/>
+                <a:cs typeface="Calibri" pitchFamily="34" charset="-120"/>
+              </a:rPr>
+              <a:t>Job mengirim 30 POST /deploy serentak ke orchestrator — mensimulasikan 30 mahasiswa Launch Lab bersamaan.</a:t>
+            </a:r>
+            <a:endParaRPr lang="en-US" sz="1350" dirty="0"/>
+          </a:p>
+        </p:txBody>
+      </p:sp>
+      <p:sp>
+        <p:nvSpPr>
+          <p:cNvPr id="10" name="Shape 8"/>
+          <p:cNvSpPr/>
+          <p:nvPr/>
+        </p:nvSpPr>
+        <p:spPr>
+          <a:xfrm>
+            <a:off x="6324448" y="1783080"/>
+            <a:ext cx="5227168" cy="1965960"/>
+          </a:xfrm>
+          <a:prstGeom prst="roundRect">
+            <a:avLst>
+              <a:gd name="adj" fmla="val 3721"/>
+            </a:avLst>
+          </a:prstGeom>
+          <a:solidFill>
+            <a:srgbClr val="F3F6F8"/>
+          </a:solidFill>
+          <a:ln w="12700">
+            <a:solidFill>
+              <a:srgbClr val="E1E8ED"/>
+            </a:solidFill>
+            <a:prstDash val="solid"/>
+          </a:ln>
+        </p:spPr>
+      </p:sp>
+      <p:sp>
+        <p:nvSpPr>
+          <p:cNvPr id="11" name="Shape 9"/>
+          <p:cNvSpPr/>
+          <p:nvPr/>
+        </p:nvSpPr>
+        <p:spPr>
+          <a:xfrm>
+            <a:off x="6598768" y="2075688"/>
+            <a:ext cx="457200" cy="457200"/>
+          </a:xfrm>
+          <a:prstGeom prst="ellipse">
+            <a:avLst/>
+          </a:prstGeom>
+          <a:solidFill>
+            <a:srgbClr val="0F2A43"/>
+          </a:solidFill>
+          <a:ln/>
+        </p:spPr>
+      </p:sp>
+      <p:sp>
+        <p:nvSpPr>
+          <p:cNvPr id="12" name="Text 10"/>
+          <p:cNvSpPr/>
+          <p:nvPr/>
+        </p:nvSpPr>
+        <p:spPr>
+          <a:xfrm>
+            <a:off x="6598768" y="2075688"/>
+            <a:ext cx="457200" cy="457200"/>
+          </a:xfrm>
+          <a:prstGeom prst="rect">
+            <a:avLst/>
+          </a:prstGeom>
+          <a:noFill/>
+          <a:ln/>
+        </p:spPr>
+        <p:txBody>
+          <a:bodyPr wrap="square" rtlCol="0" anchor="ctr"/>
+          <a:lstStyle/>
+          <a:p>
+            <a:pPr algn="ctr" indent="0" marL="0">
+              <a:buNone/>
+            </a:pPr>
+            <a:r>
+              <a:rPr lang="en-US" sz="1800" b="1" dirty="0">
+                <a:solidFill>
+                  <a:srgbClr val="FFFFFF"/>
+                </a:solidFill>
+                <a:latin typeface="Cambria" pitchFamily="34" charset="0"/>
+                <a:ea typeface="Cambria" pitchFamily="34" charset="-122"/>
+                <a:cs typeface="Cambria" pitchFamily="34" charset="-120"/>
+              </a:rPr>
+              <a:t>2</a:t>
+            </a:r>
+            <a:endParaRPr lang="en-US" sz="1800" dirty="0"/>
+          </a:p>
+        </p:txBody>
+      </p:sp>
+      <p:sp>
+        <p:nvSpPr>
+          <p:cNvPr id="13" name="Text 11"/>
+          <p:cNvSpPr/>
+          <p:nvPr/>
+        </p:nvSpPr>
+        <p:spPr>
+          <a:xfrm>
+            <a:off x="7238848" y="2039112"/>
+            <a:ext cx="4038448" cy="365760"/>
+          </a:xfrm>
+          <a:prstGeom prst="rect">
+            <a:avLst/>
+          </a:prstGeom>
+          <a:noFill/>
+          <a:ln/>
+        </p:spPr>
+        <p:txBody>
+          <a:bodyPr wrap="square" rtlCol="0" anchor="ctr"/>
+          <a:lstStyle/>
+          <a:p>
+            <a:pPr indent="0" marL="0">
+              <a:buNone/>
+            </a:pPr>
+            <a:r>
+              <a:rPr lang="en-US" sz="1700" b="1" dirty="0">
+                <a:solidFill>
+                  <a:srgbClr val="0F2A43"/>
+                </a:solidFill>
+                <a:latin typeface="Cambria" pitchFamily="34" charset="0"/>
+                <a:ea typeface="Cambria" pitchFamily="34" charset="-122"/>
+                <a:cs typeface="Cambria" pitchFamily="34" charset="-120"/>
+              </a:rPr>
+              <a:t>Target &amp; lingkungan</a:t>
+            </a:r>
+            <a:endParaRPr lang="en-US" sz="1700" dirty="0"/>
+          </a:p>
+        </p:txBody>
+      </p:sp>
+      <p:sp>
+        <p:nvSpPr>
+          <p:cNvPr id="14" name="Text 12"/>
+          <p:cNvSpPr/>
+          <p:nvPr/>
+        </p:nvSpPr>
+        <p:spPr>
+          <a:xfrm>
+            <a:off x="7238848" y="2404872"/>
+            <a:ext cx="4038448" cy="320040"/>
+          </a:xfrm>
+          <a:prstGeom prst="rect">
+            <a:avLst/>
+          </a:prstGeom>
+          <a:noFill/>
+          <a:ln/>
+        </p:spPr>
+        <p:txBody>
+          <a:bodyPr wrap="square" rtlCol="0" anchor="ctr"/>
+          <a:lstStyle/>
+          <a:p>
+            <a:pPr indent="0" marL="0">
+              <a:buNone/>
+            </a:pPr>
+            <a:r>
+              <a:rPr lang="en-US" sz="1150" b="1" dirty="0">
+                <a:solidFill>
+                  <a:srgbClr val="0F2A43"/>
+                </a:solidFill>
+                <a:latin typeface="Consolas" pitchFamily="34" charset="0"/>
+                <a:ea typeface="Consolas" pitchFamily="34" charset="-122"/>
+                <a:cs typeface="Consolas" pitchFamily="34" charset="-120"/>
+              </a:rPr>
+              <a:t>POST /deploy → 1 pod lab</a:t>
+            </a:r>
+            <a:endParaRPr lang="en-US" sz="1150" dirty="0"/>
+          </a:p>
+        </p:txBody>
+      </p:sp>
+      <p:sp>
+        <p:nvSpPr>
+          <p:cNvPr id="15" name="Text 13"/>
+          <p:cNvSpPr/>
+          <p:nvPr/>
+        </p:nvSpPr>
+        <p:spPr>
+          <a:xfrm>
+            <a:off x="6598768" y="2834640"/>
+            <a:ext cx="4678528" cy="822960"/>
+          </a:xfrm>
+          <a:prstGeom prst="rect">
+            <a:avLst/>
+          </a:prstGeom>
+          <a:noFill/>
+          <a:ln/>
+        </p:spPr>
+        <p:txBody>
+          <a:bodyPr wrap="square" rtlCol="0" anchor="t"/>
+          <a:lstStyle/>
+          <a:p>
+            <a:pPr indent="0" marL="0">
+              <a:buNone/>
+            </a:pPr>
+            <a:r>
+              <a:rPr lang="en-US" sz="1350" dirty="0">
+                <a:solidFill>
+                  <a:srgbClr val="1E2933"/>
+                </a:solidFill>
+                <a:latin typeface="Calibri" pitchFamily="34" charset="0"/>
+                <a:ea typeface="Calibri" pitchFamily="34" charset="-122"/>
+                <a:cs typeface="Calibri" pitchFamily="34" charset="-120"/>
+              </a:rPr>
+              <a:t>Cluster Kubernetes OKE (node ARM A1) di Batam; tiap permintaan membuat 1 pod lab Jupyter.</a:t>
+            </a:r>
+            <a:endParaRPr lang="en-US" sz="1350" dirty="0"/>
+          </a:p>
+        </p:txBody>
+      </p:sp>
+      <p:sp>
+        <p:nvSpPr>
+          <p:cNvPr id="16" name="Shape 14"/>
+          <p:cNvSpPr/>
+          <p:nvPr/>
+        </p:nvSpPr>
+        <p:spPr>
+          <a:xfrm>
+            <a:off x="640080" y="4069080"/>
+            <a:ext cx="5227168" cy="1965960"/>
+          </a:xfrm>
+          <a:prstGeom prst="roundRect">
+            <a:avLst>
+              <a:gd name="adj" fmla="val 3721"/>
+            </a:avLst>
+          </a:prstGeom>
+          <a:solidFill>
+            <a:srgbClr val="F3F6F8"/>
+          </a:solidFill>
+          <a:ln w="12700">
+            <a:solidFill>
+              <a:srgbClr val="E1E8ED"/>
+            </a:solidFill>
+            <a:prstDash val="solid"/>
+          </a:ln>
+        </p:spPr>
+      </p:sp>
+      <p:sp>
+        <p:nvSpPr>
+          <p:cNvPr id="17" name="Shape 15"/>
+          <p:cNvSpPr/>
+          <p:nvPr/>
+        </p:nvSpPr>
+        <p:spPr>
+          <a:xfrm>
+            <a:off x="914400" y="4361688"/>
+            <a:ext cx="457200" cy="457200"/>
+          </a:xfrm>
+          <a:prstGeom prst="ellipse">
+            <a:avLst/>
+          </a:prstGeom>
+          <a:solidFill>
+            <a:srgbClr val="2FA36B"/>
+          </a:solidFill>
+          <a:ln/>
+        </p:spPr>
+      </p:sp>
+      <p:sp>
+        <p:nvSpPr>
+          <p:cNvPr id="18" name="Text 16"/>
+          <p:cNvSpPr/>
+          <p:nvPr/>
+        </p:nvSpPr>
+        <p:spPr>
+          <a:xfrm>
+            <a:off x="914400" y="4361688"/>
+            <a:ext cx="457200" cy="457200"/>
+          </a:xfrm>
+          <a:prstGeom prst="rect">
+            <a:avLst/>
+          </a:prstGeom>
+          <a:noFill/>
+          <a:ln/>
+        </p:spPr>
+        <p:txBody>
+          <a:bodyPr wrap="square" rtlCol="0" anchor="ctr"/>
+          <a:lstStyle/>
+          <a:p>
+            <a:pPr algn="ctr" indent="0" marL="0">
+              <a:buNone/>
+            </a:pPr>
+            <a:r>
+              <a:rPr lang="en-US" sz="1800" b="1" dirty="0">
+                <a:solidFill>
+                  <a:srgbClr val="FFFFFF"/>
+                </a:solidFill>
+                <a:latin typeface="Cambria" pitchFamily="34" charset="0"/>
+                <a:ea typeface="Cambria" pitchFamily="34" charset="-122"/>
+                <a:cs typeface="Cambria" pitchFamily="34" charset="-120"/>
+              </a:rPr>
+              <a:t>3</a:t>
+            </a:r>
+            <a:endParaRPr lang="en-US" sz="1800" dirty="0"/>
+          </a:p>
+        </p:txBody>
+      </p:sp>
+      <p:sp>
+        <p:nvSpPr>
+          <p:cNvPr id="19" name="Text 17"/>
+          <p:cNvSpPr/>
+          <p:nvPr/>
+        </p:nvSpPr>
+        <p:spPr>
+          <a:xfrm>
+            <a:off x="1554480" y="4325112"/>
+            <a:ext cx="4038448" cy="365760"/>
+          </a:xfrm>
+          <a:prstGeom prst="rect">
+            <a:avLst/>
+          </a:prstGeom>
+          <a:noFill/>
+          <a:ln/>
+        </p:spPr>
+        <p:txBody>
+          <a:bodyPr wrap="square" rtlCol="0" anchor="ctr"/>
+          <a:lstStyle/>
+          <a:p>
+            <a:pPr indent="0" marL="0">
+              <a:buNone/>
+            </a:pPr>
+            <a:r>
+              <a:rPr lang="en-US" sz="1700" b="1" dirty="0">
+                <a:solidFill>
+                  <a:srgbClr val="0F2A43"/>
+                </a:solidFill>
+                <a:latin typeface="Cambria" pitchFamily="34" charset="0"/>
+                <a:ea typeface="Cambria" pitchFamily="34" charset="-122"/>
+                <a:cs typeface="Cambria" pitchFamily="34" charset="-120"/>
+              </a:rPr>
+              <a:t>Batas skala node</a:t>
+            </a:r>
+            <a:endParaRPr lang="en-US" sz="1700" dirty="0"/>
+          </a:p>
+        </p:txBody>
+      </p:sp>
+      <p:sp>
+        <p:nvSpPr>
+          <p:cNvPr id="20" name="Text 18"/>
+          <p:cNvSpPr/>
+          <p:nvPr/>
+        </p:nvSpPr>
+        <p:spPr>
+          <a:xfrm>
+            <a:off x="1554480" y="4690872"/>
+            <a:ext cx="4038448" cy="320040"/>
+          </a:xfrm>
+          <a:prstGeom prst="rect">
+            <a:avLst/>
+          </a:prstGeom>
+          <a:noFill/>
+          <a:ln/>
+        </p:spPr>
+        <p:txBody>
+          <a:bodyPr wrap="square" rtlCol="0" anchor="ctr"/>
+          <a:lstStyle/>
+          <a:p>
+            <a:pPr indent="0" marL="0">
+              <a:buNone/>
+            </a:pPr>
+            <a:r>
+              <a:rPr lang="en-US" sz="1150" b="1" dirty="0">
+                <a:solidFill>
+                  <a:srgbClr val="2FA36B"/>
+                </a:solidFill>
+                <a:latin typeface="Consolas" pitchFamily="34" charset="0"/>
+                <a:ea typeface="Consolas" pitchFamily="34" charset="-122"/>
+                <a:cs typeface="Consolas" pitchFamily="34" charset="-120"/>
+              </a:rPr>
+              <a:t>--nodes=1:3</a:t>
+            </a:r>
+            <a:endParaRPr lang="en-US" sz="1150" dirty="0"/>
+          </a:p>
+        </p:txBody>
+      </p:sp>
+      <p:sp>
+        <p:nvSpPr>
+          <p:cNvPr id="21" name="Text 19"/>
+          <p:cNvSpPr/>
+          <p:nvPr/>
+        </p:nvSpPr>
+        <p:spPr>
+          <a:xfrm>
+            <a:off x="914400" y="5120640"/>
+            <a:ext cx="4678528" cy="822960"/>
+          </a:xfrm>
+          <a:prstGeom prst="rect">
+            <a:avLst/>
+          </a:prstGeom>
+          <a:noFill/>
+          <a:ln/>
+        </p:spPr>
+        <p:txBody>
+          <a:bodyPr wrap="square" rtlCol="0" anchor="t"/>
+          <a:lstStyle/>
+          <a:p>
+            <a:pPr indent="0" marL="0">
+              <a:buNone/>
+            </a:pPr>
+            <a:r>
+              <a:rPr lang="en-US" sz="1350" dirty="0">
+                <a:solidFill>
+                  <a:srgbClr val="1E2933"/>
+                </a:solidFill>
+                <a:latin typeface="Calibri" pitchFamily="34" charset="0"/>
+                <a:ea typeface="Calibri" pitchFamily="34" charset="-122"/>
+                <a:cs typeface="Calibri" pitchFamily="34" charset="-120"/>
+              </a:rPr>
+              <a:t>Node awal 1; Cluster Autoscaler boleh menambah hingga 3 node saat antrean muncul (kendali biaya).</a:t>
+            </a:r>
+            <a:endParaRPr lang="en-US" sz="1350" dirty="0"/>
+          </a:p>
+        </p:txBody>
+      </p:sp>
+      <p:sp>
+        <p:nvSpPr>
+          <p:cNvPr id="22" name="Shape 20"/>
+          <p:cNvSpPr/>
+          <p:nvPr/>
+        </p:nvSpPr>
+        <p:spPr>
+          <a:xfrm>
+            <a:off x="6324448" y="4069080"/>
+            <a:ext cx="5227168" cy="1965960"/>
+          </a:xfrm>
+          <a:prstGeom prst="roundRect">
+            <a:avLst>
+              <a:gd name="adj" fmla="val 3721"/>
+            </a:avLst>
+          </a:prstGeom>
+          <a:solidFill>
+            <a:srgbClr val="F3F6F8"/>
+          </a:solidFill>
+          <a:ln w="12700">
+            <a:solidFill>
+              <a:srgbClr val="E1E8ED"/>
+            </a:solidFill>
+            <a:prstDash val="solid"/>
+          </a:ln>
+        </p:spPr>
+      </p:sp>
+      <p:sp>
+        <p:nvSpPr>
+          <p:cNvPr id="23" name="Shape 21"/>
+          <p:cNvSpPr/>
+          <p:nvPr/>
+        </p:nvSpPr>
+        <p:spPr>
+          <a:xfrm>
+            <a:off x="6598768" y="4361688"/>
+            <a:ext cx="457200" cy="457200"/>
+          </a:xfrm>
+          <a:prstGeom prst="ellipse">
+            <a:avLst/>
+          </a:prstGeom>
+          <a:solidFill>
+            <a:srgbClr val="E08A1E"/>
+          </a:solidFill>
+          <a:ln/>
+        </p:spPr>
+      </p:sp>
+      <p:sp>
+        <p:nvSpPr>
+          <p:cNvPr id="24" name="Text 22"/>
+          <p:cNvSpPr/>
+          <p:nvPr/>
+        </p:nvSpPr>
+        <p:spPr>
+          <a:xfrm>
+            <a:off x="6598768" y="4361688"/>
+            <a:ext cx="457200" cy="457200"/>
+          </a:xfrm>
+          <a:prstGeom prst="rect">
+            <a:avLst/>
+          </a:prstGeom>
+          <a:noFill/>
+          <a:ln/>
+        </p:spPr>
+        <p:txBody>
+          <a:bodyPr wrap="square" rtlCol="0" anchor="ctr"/>
+          <a:lstStyle/>
+          <a:p>
+            <a:pPr algn="ctr" indent="0" marL="0">
+              <a:buNone/>
+            </a:pPr>
+            <a:r>
+              <a:rPr lang="en-US" sz="1800" b="1" dirty="0">
+                <a:solidFill>
+                  <a:srgbClr val="FFFFFF"/>
+                </a:solidFill>
+                <a:latin typeface="Cambria" pitchFamily="34" charset="0"/>
+                <a:ea typeface="Cambria" pitchFamily="34" charset="-122"/>
+                <a:cs typeface="Cambria" pitchFamily="34" charset="-120"/>
+              </a:rPr>
+              <a:t>4</a:t>
+            </a:r>
+            <a:endParaRPr lang="en-US" sz="1800" dirty="0"/>
+          </a:p>
+        </p:txBody>
+      </p:sp>
+      <p:sp>
+        <p:nvSpPr>
+          <p:cNvPr id="25" name="Text 23"/>
+          <p:cNvSpPr/>
+          <p:nvPr/>
+        </p:nvSpPr>
+        <p:spPr>
+          <a:xfrm>
+            <a:off x="7238848" y="4325112"/>
+            <a:ext cx="4038448" cy="365760"/>
+          </a:xfrm>
+          <a:prstGeom prst="rect">
+            <a:avLst/>
+          </a:prstGeom>
+          <a:noFill/>
+          <a:ln/>
+        </p:spPr>
+        <p:txBody>
+          <a:bodyPr wrap="square" rtlCol="0" anchor="ctr"/>
+          <a:lstStyle/>
+          <a:p>
+            <a:pPr indent="0" marL="0">
+              <a:buNone/>
+            </a:pPr>
+            <a:r>
+              <a:rPr lang="en-US" sz="1700" b="1" dirty="0">
+                <a:solidFill>
+                  <a:srgbClr val="0F2A43"/>
+                </a:solidFill>
+                <a:latin typeface="Cambria" pitchFamily="34" charset="0"/>
+                <a:ea typeface="Cambria" pitchFamily="34" charset="-122"/>
+                <a:cs typeface="Cambria" pitchFamily="34" charset="-120"/>
+              </a:rPr>
+              <a:t>Kriteria sukses</a:t>
+            </a:r>
+            <a:endParaRPr lang="en-US" sz="1700" dirty="0"/>
+          </a:p>
+        </p:txBody>
+      </p:sp>
+      <p:sp>
+        <p:nvSpPr>
+          <p:cNvPr id="26" name="Text 24"/>
+          <p:cNvSpPr/>
+          <p:nvPr/>
+        </p:nvSpPr>
+        <p:spPr>
+          <a:xfrm>
+            <a:off x="7238848" y="4690872"/>
+            <a:ext cx="4038448" cy="320040"/>
+          </a:xfrm>
+          <a:prstGeom prst="rect">
+            <a:avLst/>
+          </a:prstGeom>
+          <a:noFill/>
+          <a:ln/>
+        </p:spPr>
+        <p:txBody>
+          <a:bodyPr wrap="square" rtlCol="0" anchor="ctr"/>
+          <a:lstStyle/>
+          <a:p>
+            <a:pPr indent="0" marL="0">
+              <a:buNone/>
+            </a:pPr>
+            <a:r>
+              <a:rPr lang="en-US" sz="1150" b="1" dirty="0">
+                <a:solidFill>
+                  <a:srgbClr val="E08A1E"/>
+                </a:solidFill>
+                <a:latin typeface="Consolas" pitchFamily="34" charset="0"/>
+                <a:ea typeface="Consolas" pitchFamily="34" charset="-122"/>
+                <a:cs typeface="Consolas" pitchFamily="34" charset="-120"/>
+              </a:rPr>
+              <a:t>lab_pending → 0</a:t>
+            </a:r>
+            <a:endParaRPr lang="en-US" sz="1150" dirty="0"/>
+          </a:p>
+        </p:txBody>
+      </p:sp>
+      <p:sp>
+        <p:nvSpPr>
+          <p:cNvPr id="27" name="Text 25"/>
+          <p:cNvSpPr/>
+          <p:nvPr/>
+        </p:nvSpPr>
+        <p:spPr>
+          <a:xfrm>
+            <a:off x="6598768" y="5120640"/>
+            <a:ext cx="4678528" cy="822960"/>
+          </a:xfrm>
+          <a:prstGeom prst="rect">
+            <a:avLst/>
+          </a:prstGeom>
+          <a:noFill/>
+          <a:ln/>
+        </p:spPr>
+        <p:txBody>
+          <a:bodyPr wrap="square" rtlCol="0" anchor="t"/>
+          <a:lstStyle/>
+          <a:p>
+            <a:pPr indent="0" marL="0">
+              <a:buNone/>
+            </a:pPr>
+            <a:r>
+              <a:rPr lang="en-US" sz="1350" dirty="0">
+                <a:solidFill>
+                  <a:srgbClr val="1E2933"/>
+                </a:solidFill>
+                <a:latin typeface="Calibri" pitchFamily="34" charset="0"/>
+                <a:ea typeface="Calibri" pitchFamily="34" charset="-122"/>
+                <a:cs typeface="Calibri" pitchFamily="34" charset="-120"/>
+              </a:rPr>
+              <a:t>Berhasil bila node bertambah otomatis mengikuti antrean &amp; Pending kembali 0 tanpa intervensi manual.</a:t>
             </a:r>
             <a:endParaRPr lang="en-US" sz="1350" dirty="0"/>
           </a:p>

</xml_diff>